<commit_message>
第 1 節第 10 張：介紹 onsemi 與 AR0233AT
兩顆光達都有好好介紹（旋轉式／固定式、誰在用），相機那一顆只有一句
「就是相機裡面那塊晶片」就帶過去了。補三句：

  onsemi 是美國半導體公司，前身 ON Semiconductor，2021 年改成全小寫。
  影像感測器來自 2014 年併購的 Aptina——所以型號是 AR 開頭，那是 Aptina
  留下來的產品線代號。車用這一塊最常碰到 onsemi、Sony、OmniVision 三家。

  型號結尾的 AT：onsemi 的車規型號習慣用 AT 結尾（AR0233AT、AR0234AT），
  同一顆的非車規版本換別的後綴（AR0234CS）。

  最重要的一句：onsemi 賣的是「晶片」，不是「相機」——鏡頭要自己配。

第三句是刻意放在這裡的：它就是這一張「為什麼找不到視野」的答案，先讓學生
記著，找不到的時候才會自己想通，而不是等第 11 張揭曉。

講義 3.1 也加同一個方塊，放在「相機的規格表上沒有視野」那一節開頭。
併購年份與改名年份查過（2014 年 8 月完成併購、2021 年 8 月改名）；市佔數字
沒有引用，因為查到的是 2014 年全影像感測器市場的數字，不是車用這一塊。

Co-Authored-By: Claude Opus 5 (1M context) <noreply@anthropic.com>
</commit_message>
<xml_diff>
--- a/第五週(10-08)/第五週_第1節_簡報.pptx
+++ b/第五週(10-08)/第五週_第1節_簡報.pptx
@@ -1190,11 +1190,11 @@
                 <a:spcPts val="0"/>
               </a:spcBef>
               <a:spcAft>
-                <a:spcPts val="150"/>
-              </a:spcAft>
-            </a:pPr>
-            <a:r>
-              <a:rPr sz="900" b="1" lang="zh-TW" dirty="0">
+                <a:spcPts val="133"/>
+              </a:spcAft>
+            </a:pPr>
+            <a:r>
+              <a:rPr sz="800" b="1" lang="zh-TW" dirty="0">
                 <a:solidFill>
                   <a:srgbClr val="000000"/>
                 </a:solidFill>
@@ -1205,7 +1205,7 @@
               <a:t>▍這一張要做什麼</a:t>
             </a:r>
             <a:r>
-              <a:rPr sz="900" lang="zh-TW" dirty="0">
+              <a:rPr sz="800" lang="zh-TW" dirty="0">
                 <a:solidFill>
                   <a:srgbClr val="000000"/>
                 </a:solidFill>
@@ -1223,11 +1223,11 @@
                 <a:spcPts val="0"/>
               </a:spcBef>
               <a:spcAft>
-                <a:spcPts val="150"/>
-              </a:spcAft>
-            </a:pPr>
-            <a:r>
-              <a:rPr sz="900" lang="zh-TW" dirty="0">
+                <a:spcPts val="133"/>
+              </a:spcAft>
+            </a:pPr>
+            <a:r>
+              <a:rPr sz="800" lang="zh-TW" dirty="0">
                 <a:solidFill>
                   <a:srgbClr val="000000"/>
                 </a:solidFill>
@@ -1245,11 +1245,11 @@
                 <a:spcPts val="0"/>
               </a:spcBef>
               <a:spcAft>
-                <a:spcPts val="150"/>
-              </a:spcAft>
-            </a:pPr>
-            <a:r>
-              <a:rPr sz="900" b="1" lang="zh-TW" dirty="0">
+                <a:spcPts val="133"/>
+              </a:spcAft>
+            </a:pPr>
+            <a:r>
+              <a:rPr sz="800" b="1" lang="zh-TW" dirty="0">
                 <a:solidFill>
                   <a:srgbClr val="000000"/>
                 </a:solidFill>
@@ -1260,7 +1260,7 @@
               <a:t>▍畫面上圈這裡</a:t>
             </a:r>
             <a:r>
-              <a:rPr sz="900" lang="zh-TW" dirty="0">
+              <a:rPr sz="800" lang="zh-TW" dirty="0">
                 <a:solidFill>
                   <a:srgbClr val="000000"/>
                 </a:solidFill>
@@ -1278,11 +1278,11 @@
                 <a:spcPts val="0"/>
               </a:spcBef>
               <a:spcAft>
-                <a:spcPts val="150"/>
-              </a:spcAft>
-            </a:pPr>
-            <a:r>
-              <a:rPr sz="900" lang="zh-TW" dirty="0">
+                <a:spcPts val="133"/>
+              </a:spcAft>
+            </a:pPr>
+            <a:r>
+              <a:rPr sz="800" lang="zh-TW" dirty="0">
                 <a:solidFill>
                   <a:srgbClr val="000000"/>
                 </a:solidFill>
@@ -1300,11 +1300,11 @@
                 <a:spcPts val="0"/>
               </a:spcBef>
               <a:spcAft>
-                <a:spcPts val="150"/>
-              </a:spcAft>
-            </a:pPr>
-            <a:r>
-              <a:rPr sz="900" b="1" lang="zh-TW" dirty="0">
+                <a:spcPts val="133"/>
+              </a:spcAft>
+            </a:pPr>
+            <a:r>
+              <a:rPr sz="800" b="1" lang="zh-TW" dirty="0">
                 <a:solidFill>
                   <a:srgbClr val="000000"/>
                 </a:solidFill>
@@ -1315,7 +1315,7 @@
               <a:t>▍以下照著唸</a:t>
             </a:r>
             <a:r>
-              <a:rPr sz="900" lang="zh-TW" dirty="0">
+              <a:rPr sz="800" lang="zh-TW" dirty="0">
                 <a:solidFill>
                   <a:srgbClr val="000000"/>
                 </a:solidFill>
@@ -1333,19 +1333,19 @@
                 <a:spcPts val="0"/>
               </a:spcBef>
               <a:spcAft>
-                <a:spcPts val="150"/>
-              </a:spcAft>
-            </a:pPr>
-            <a:r>
-              <a:rPr sz="900" lang="zh-TW" dirty="0">
-                <a:solidFill>
-                  <a:srgbClr val="000000"/>
-                </a:solidFill>
-                <a:latin typeface="Arial Unicode MS"/>
-                <a:ea typeface="Arial Unicode MS"/>
-                <a:cs typeface="Arial Unicode MS"/>
-              </a:rPr>
-              <a:t>第三個型號，onsemi 的 AR0233AT，就是相機裡面那塊晶片。左邊這張是從 onsemi 的公開文件直接剪下來的，出處印在圖下面。
+                <a:spcPts val="133"/>
+              </a:spcAft>
+            </a:pPr>
+            <a:r>
+              <a:rPr sz="800" lang="zh-TW" dirty="0">
+                <a:solidFill>
+                  <a:srgbClr val="000000"/>
+                </a:solidFill>
+                <a:latin typeface="Arial Unicode MS"/>
+                <a:ea typeface="Arial Unicode MS"/>
+                <a:cs typeface="Arial Unicode MS"/>
+              </a:rPr>
+              <a:t>第三個型號，onsemi 的 AR0233AT。這一顆各位比較陌生，我用三句話介紹。
 </a:t>
             </a:r>
           </a:p>
@@ -1355,11 +1355,198 @@
                 <a:spcPts val="0"/>
               </a:spcBef>
               <a:spcAft>
-                <a:spcPts val="150"/>
-              </a:spcAft>
-            </a:pPr>
-            <a:r>
-              <a:rPr sz="900" lang="zh-TW" dirty="0">
+                <a:spcPts val="133"/>
+              </a:spcAft>
+            </a:pPr>
+            <a:r>
+              <a:rPr sz="800" b="1" lang="zh-TW" dirty="0">
+                <a:solidFill>
+                  <a:srgbClr val="000000"/>
+                </a:solidFill>
+                <a:latin typeface="Arial Unicode MS"/>
+                <a:ea typeface="Arial Unicode MS"/>
+                <a:cs typeface="Arial Unicode MS"/>
+              </a:rPr>
+              <a:t>onsemi 是一家美國的半導體公司</a:t>
+            </a:r>
+            <a:r>
+              <a:rPr sz="800" lang="zh-TW" dirty="0">
+                <a:solidFill>
+                  <a:srgbClr val="000000"/>
+                </a:solidFill>
+                <a:latin typeface="Arial Unicode MS"/>
+                <a:ea typeface="Arial Unicode MS"/>
+                <a:cs typeface="Arial Unicode MS"/>
+              </a:rPr>
+              <a:t>，以前叫 ON Semiconductor，二〇二一年改成現在這個全小寫的寫法。它的影像感測器是二〇一四年買下一家叫 </a:t>
+            </a:r>
+            <a:r>
+              <a:rPr sz="800" b="1" lang="zh-TW" dirty="0">
+                <a:solidFill>
+                  <a:srgbClr val="000000"/>
+                </a:solidFill>
+                <a:latin typeface="Arial Unicode MS"/>
+                <a:ea typeface="Arial Unicode MS"/>
+                <a:cs typeface="Arial Unicode MS"/>
+              </a:rPr>
+              <a:t>Aptina</a:t>
+            </a:r>
+            <a:r>
+              <a:rPr sz="800" lang="zh-TW" dirty="0">
+                <a:solidFill>
+                  <a:srgbClr val="000000"/>
+                </a:solidFill>
+                <a:latin typeface="Arial Unicode MS"/>
+                <a:ea typeface="Arial Unicode MS"/>
+                <a:cs typeface="Arial Unicode MS"/>
+              </a:rPr>
+              <a:t> 的公司來的——所以型號才是 </a:t>
+            </a:r>
+            <a:r>
+              <a:rPr sz="800" b="1" lang="zh-TW" dirty="0">
+                <a:solidFill>
+                  <a:srgbClr val="000000"/>
+                </a:solidFill>
+                <a:latin typeface="Arial Unicode MS"/>
+                <a:ea typeface="Arial Unicode MS"/>
+                <a:cs typeface="Arial Unicode MS"/>
+              </a:rPr>
+              <a:t>AR</a:t>
+            </a:r>
+            <a:r>
+              <a:rPr sz="800" lang="zh-TW" dirty="0">
+                <a:solidFill>
+                  <a:srgbClr val="000000"/>
+                </a:solidFill>
+                <a:latin typeface="Arial Unicode MS"/>
+                <a:ea typeface="Arial Unicode MS"/>
+                <a:cs typeface="Arial Unicode MS"/>
+              </a:rPr>
+              <a:t> 開頭，那是 Aptina 留下來的產品線代號。車用影像感測器這一塊，最常碰到的就是 onsemi、Sony、OmniVision 這三家。
+</a:t>
+            </a:r>
+          </a:p>
+          <a:p>
+            <a:pPr algn="l">
+              <a:spcBef>
+                <a:spcPts val="0"/>
+              </a:spcBef>
+              <a:spcAft>
+                <a:spcPts val="133"/>
+              </a:spcAft>
+            </a:pPr>
+            <a:r>
+              <a:rPr sz="800" b="1" lang="zh-TW" dirty="0">
+                <a:solidFill>
+                  <a:srgbClr val="000000"/>
+                </a:solidFill>
+                <a:latin typeface="Arial Unicode MS"/>
+                <a:ea typeface="Arial Unicode MS"/>
+                <a:cs typeface="Arial Unicode MS"/>
+              </a:rPr>
+              <a:t>第二句，看型號的結尾。</a:t>
+            </a:r>
+            <a:r>
+              <a:rPr sz="800" lang="zh-TW" dirty="0">
+                <a:solidFill>
+                  <a:srgbClr val="000000"/>
+                </a:solidFill>
+                <a:latin typeface="Arial Unicode MS"/>
+                <a:ea typeface="Arial Unicode MS"/>
+                <a:cs typeface="Arial Unicode MS"/>
+              </a:rPr>
+              <a:t>onsemi 的車規型號習慣用 </a:t>
+            </a:r>
+            <a:r>
+              <a:rPr sz="800" b="1" lang="zh-TW" dirty="0">
+                <a:solidFill>
+                  <a:srgbClr val="000000"/>
+                </a:solidFill>
+                <a:latin typeface="Arial Unicode MS"/>
+                <a:ea typeface="Arial Unicode MS"/>
+                <a:cs typeface="Arial Unicode MS"/>
+              </a:rPr>
+              <a:t>AT</a:t>
+            </a:r>
+            <a:r>
+              <a:rPr sz="800" lang="zh-TW" dirty="0">
+                <a:solidFill>
+                  <a:srgbClr val="000000"/>
+                </a:solidFill>
+                <a:latin typeface="Arial Unicode MS"/>
+                <a:ea typeface="Arial Unicode MS"/>
+                <a:cs typeface="Arial Unicode MS"/>
+              </a:rPr>
+              <a:t> 結尾——AR0233AT、AR0234AT 都是；同一顆晶片的非車規版本會換成別的後綴，像 AR0234CS。看到 AT，大概就知道它是衝著車用來的。
+</a:t>
+            </a:r>
+          </a:p>
+          <a:p>
+            <a:pPr algn="l">
+              <a:spcBef>
+                <a:spcPts val="0"/>
+              </a:spcBef>
+              <a:spcAft>
+                <a:spcPts val="133"/>
+              </a:spcAft>
+            </a:pPr>
+            <a:r>
+              <a:rPr sz="800" b="1" lang="zh-TW" dirty="0">
+                <a:solidFill>
+                  <a:srgbClr val="000000"/>
+                </a:solidFill>
+                <a:latin typeface="Arial Unicode MS"/>
+                <a:ea typeface="Arial Unicode MS"/>
+                <a:cs typeface="Arial Unicode MS"/>
+              </a:rPr>
+              <a:t>第三句，也是今天最重要的一句：onsemi 賣的是「晶片」，不是「相機」。</a:t>
+            </a:r>
+            <a:r>
+              <a:rPr sz="800" lang="zh-TW" dirty="0">
+                <a:solidFill>
+                  <a:srgbClr val="000000"/>
+                </a:solidFill>
+                <a:latin typeface="Arial Unicode MS"/>
+                <a:ea typeface="Arial Unicode MS"/>
+                <a:cs typeface="Arial Unicode MS"/>
+              </a:rPr>
+              <a:t>它出貨的是一塊方方的感光晶片，鏡頭要你自己配。各位先把這句話記著，等一下找不到視野的時候會用到。
+</a:t>
+            </a:r>
+          </a:p>
+          <a:p>
+            <a:pPr algn="l">
+              <a:spcBef>
+                <a:spcPts val="0"/>
+              </a:spcBef>
+              <a:spcAft>
+                <a:spcPts val="133"/>
+              </a:spcAft>
+            </a:pPr>
+            <a:r>
+              <a:rPr sz="800" lang="zh-TW" dirty="0">
+                <a:solidFill>
+                  <a:srgbClr val="000000"/>
+                </a:solidFill>
+                <a:latin typeface="Arial Unicode MS"/>
+                <a:ea typeface="Arial Unicode MS"/>
+                <a:cs typeface="Arial Unicode MS"/>
+              </a:rPr>
+              <a:t>左邊這張是從 onsemi 的公開文件直接剪下來的，出處印在圖下面。
+</a:t>
+            </a:r>
+          </a:p>
+          <a:p>
+            <a:pPr algn="l">
+              <a:spcBef>
+                <a:spcPts val="0"/>
+              </a:spcBef>
+              <a:spcAft>
+                <a:spcPts val="133"/>
+              </a:spcAft>
+            </a:pPr>
+            <a:r>
+              <a:rPr sz="800" lang="zh-TW" dirty="0">
                 <a:solidFill>
                   <a:srgbClr val="000000"/>
                 </a:solidFill>
@@ -1370,7 +1557,7 @@
               <a:t>我們先看它有什麼。最上面一行 Optical format，是感光面的大小。第二行 </a:t>
             </a:r>
             <a:r>
-              <a:rPr sz="900" b="1" lang="zh-TW" dirty="0">
+              <a:rPr sz="800" b="1" lang="zh-TW" dirty="0">
                 <a:solidFill>
                   <a:srgbClr val="000000"/>
                 </a:solidFill>
@@ -1381,7 +1568,7 @@
               <a:t>Active pixels，2048 乘 1280</a:t>
             </a:r>
             <a:r>
-              <a:rPr sz="900" lang="zh-TW" dirty="0">
+              <a:rPr sz="800" lang="zh-TW" dirty="0">
                 <a:solidFill>
                   <a:srgbClr val="000000"/>
                 </a:solidFill>
@@ -1392,7 +1579,7 @@
               <a:t>，就是第四週拉的那條水平解析度。第三行 </a:t>
             </a:r>
             <a:r>
-              <a:rPr sz="900" b="1" lang="zh-TW" dirty="0">
+              <a:rPr sz="800" b="1" lang="zh-TW" dirty="0">
                 <a:solidFill>
                   <a:srgbClr val="000000"/>
                 </a:solidFill>
@@ -1403,7 +1590,7 @@
               <a:t>Pixel size，3.0 微米</a:t>
             </a:r>
             <a:r>
-              <a:rPr sz="900" lang="zh-TW" dirty="0">
+              <a:rPr sz="800" lang="zh-TW" dirty="0">
                 <a:solidFill>
                   <a:srgbClr val="000000"/>
                 </a:solidFill>
@@ -1421,11 +1608,11 @@
                 <a:spcPts val="0"/>
               </a:spcBef>
               <a:spcAft>
-                <a:spcPts val="150"/>
-              </a:spcAft>
-            </a:pPr>
-            <a:r>
-              <a:rPr sz="900" lang="zh-TW" dirty="0">
+                <a:spcPts val="133"/>
+              </a:spcAft>
+            </a:pPr>
+            <a:r>
+              <a:rPr sz="800" lang="zh-TW" dirty="0">
                 <a:solidFill>
                   <a:srgbClr val="000000"/>
                 </a:solidFill>
@@ -1443,11 +1630,11 @@
                 <a:spcPts val="0"/>
               </a:spcBef>
               <a:spcAft>
-                <a:spcPts val="150"/>
-              </a:spcAft>
-            </a:pPr>
-            <a:r>
-              <a:rPr sz="900" lang="zh-TW" dirty="0">
+                <a:spcPts val="133"/>
+              </a:spcAft>
+            </a:pPr>
+            <a:r>
+              <a:rPr sz="800" lang="zh-TW" dirty="0">
                 <a:solidFill>
                   <a:srgbClr val="000000"/>
                 </a:solidFill>
@@ -1465,11 +1652,11 @@
                 <a:spcPts val="0"/>
               </a:spcBef>
               <a:spcAft>
-                <a:spcPts val="150"/>
-              </a:spcAft>
-            </a:pPr>
-            <a:r>
-              <a:rPr sz="900" lang="zh-TW" dirty="0">
+                <a:spcPts val="133"/>
+              </a:spcAft>
+            </a:pPr>
+            <a:r>
+              <a:rPr sz="800" lang="zh-TW" dirty="0">
                 <a:solidFill>
                   <a:srgbClr val="000000"/>
                 </a:solidFill>
@@ -1487,11 +1674,11 @@
                 <a:spcPts val="0"/>
               </a:spcBef>
               <a:spcAft>
-                <a:spcPts val="150"/>
-              </a:spcAft>
-            </a:pPr>
-            <a:r>
-              <a:rPr sz="900" lang="zh-TW" dirty="0">
+                <a:spcPts val="133"/>
+              </a:spcAft>
+            </a:pPr>
+            <a:r>
+              <a:rPr sz="800" lang="zh-TW" dirty="0">
                 <a:solidFill>
                   <a:srgbClr val="000000"/>
                 </a:solidFill>
@@ -1509,11 +1696,11 @@
                 <a:spcPts val="0"/>
               </a:spcBef>
               <a:spcAft>
-                <a:spcPts val="150"/>
-              </a:spcAft>
-            </a:pPr>
-            <a:r>
-              <a:rPr sz="900" lang="zh-TW" dirty="0">
+                <a:spcPts val="133"/>
+              </a:spcAft>
+            </a:pPr>
+            <a:r>
+              <a:rPr sz="800" lang="zh-TW" dirty="0">
                 <a:solidFill>
                   <a:srgbClr val="000000"/>
                 </a:solidFill>
@@ -1524,7 +1711,7 @@
               <a:t>右邊還有一行叫 </a:t>
             </a:r>
             <a:r>
-              <a:rPr sz="900" b="1" lang="zh-TW" dirty="0">
+              <a:rPr sz="800" b="1" lang="zh-TW" dirty="0">
                 <a:solidFill>
                   <a:srgbClr val="000000"/>
                 </a:solidFill>
@@ -1535,7 +1722,7 @@
               <a:t>Focal length</a:t>
             </a:r>
             <a:r>
-              <a:rPr sz="900" lang="zh-TW" dirty="0">
+              <a:rPr sz="800" lang="zh-TW" dirty="0">
                 <a:solidFill>
                   <a:srgbClr val="000000"/>
                 </a:solidFill>
@@ -1546,7 +1733,7 @@
               <a:t>，焦距。前面兩欄是 4.74 公釐，後面兩欄是 2.75 公釐。往下看</a:t>
             </a:r>
             <a:r>
-              <a:rPr sz="900" b="1" lang="zh-TW" dirty="0">
+              <a:rPr sz="800" b="1" lang="zh-TW" dirty="0">
                 <a:solidFill>
                   <a:srgbClr val="000000"/>
                 </a:solidFill>
@@ -1557,7 +1744,7 @@
               <a:t>水平視野</a:t>
             </a:r>
             <a:r>
-              <a:rPr sz="900" lang="zh-TW" dirty="0">
+              <a:rPr sz="800" lang="zh-TW" dirty="0">
                 <a:solidFill>
                   <a:srgbClr val="000000"/>
                 </a:solidFill>
@@ -1575,11 +1762,11 @@
                 <a:spcPts val="0"/>
               </a:spcBef>
               <a:spcAft>
-                <a:spcPts val="150"/>
-              </a:spcAft>
-            </a:pPr>
-            <a:r>
-              <a:rPr sz="900" lang="zh-TW" dirty="0">
+                <a:spcPts val="133"/>
+              </a:spcAft>
+            </a:pPr>
+            <a:r>
+              <a:rPr sz="800" lang="zh-TW" dirty="0">
                 <a:solidFill>
                   <a:srgbClr val="000000"/>
                 </a:solidFill>

</xml_diff>